<commit_message>
fix(midterm): align v6 PPT metrics names with speech and outline
Rename the five layered evaluation metrics on the v6-candidate
audit slide to the full canonical names used in 讲稿-v6-candidate
and 答辩提纲; keep values unchanged; reinforce developer-verification
wording; leave v5 artifacts untouched.
</commit_message>
<xml_diff>
--- a/中期答辩材料/汇报PPT/中期汇报-v6-candidate.pptx
+++ b/中期答辩材料/汇报PPT/中期汇报-v6-candidate.pptx
@@ -8899,7 +8899,7 @@
                 </a:solidFill>
                 <a:latin typeface="Microsoft YaHei"/>
               </a:rPr>
-              <a:t>22 题分层结果（Dense / Hybrid）</a:t>
+              <a:t>22 题开发者核验（Dense / Hybrid）</a:t>
             </a:r>
           </a:p>
           <a:p>
@@ -8915,7 +8915,7 @@
                 </a:solidFill>
                 <a:latin typeface="Microsoft YaHei"/>
               </a:rPr>
-              <a:t>端到端可答题　　15/17　/　16/17</a:t>
+              <a:t>端到端可答题成功率　　　　15/17　/　16/17</a:t>
             </a:r>
           </a:p>
           <a:p>
@@ -8931,7 +8931,7 @@
                 </a:solidFill>
                 <a:latin typeface="Microsoft YaHei"/>
               </a:rPr>
-              <a:t>已答事实要点　　15/16　/　16/16</a:t>
+              <a:t>已回答题中的事实要点通过率　15/16　/　16/16</a:t>
             </a:r>
           </a:p>
           <a:p>
@@ -8947,7 +8947,7 @@
                 </a:solidFill>
                 <a:latin typeface="Microsoft YaHei"/>
               </a:rPr>
-              <a:t>已答引用支持　　16/16　/　16/16</a:t>
+              <a:t>已回答题中的引用支持通过率　16/16　/　16/16</a:t>
             </a:r>
           </a:p>
           <a:p>
@@ -8963,7 +8963,7 @@
                 </a:solidFill>
                 <a:latin typeface="Microsoft YaHei"/>
               </a:rPr>
-              <a:t>严格预期页命中　12/16　/　12/16　← 不叫引用错误率</a:t>
+              <a:t>严格预期页命中　　　　　　　12/16　/　12/16　← 不叫引用错误率</a:t>
             </a:r>
           </a:p>
           <a:p>
@@ -8979,7 +8979,7 @@
                 </a:solidFill>
                 <a:latin typeface="Microsoft YaHei"/>
               </a:rPr>
-              <a:t>明显课外拒答　　5/5　　/　5/5　　← 不可泛化困难拒答</a:t>
+              <a:t>明显课外问题正确拒答　　　　5/5　　/　5/5　　← 不可泛化困难拒答</a:t>
             </a:r>
           </a:p>
           <a:p>
@@ -9027,7 +9027,23 @@
                 </a:solidFill>
                 <a:latin typeface="Microsoft YaHei"/>
               </a:rPr>
-              <a:t>不得宣称 Hybrid 显著更优；Keyword-only→最终 evidence=0</a:t>
+              <a:t>开发者核验，非独立评测；不得宣称 Hybrid 显著更优</a:t>
+            </a:r>
+          </a:p>
+          <a:p>
+            <a:pPr algn="l">
+              <a:spcAft>
+                <a:spcPts val="200"/>
+              </a:spcAft>
+            </a:pPr>
+            <a:r>
+              <a:rPr sz="1300">
+                <a:solidFill>
+                  <a:srgbClr val="263642"/>
+                </a:solidFill>
+                <a:latin typeface="Microsoft YaHei"/>
+              </a:rPr>
+              <a:t>Keyword-only→最终 evidence=0</a:t>
             </a:r>
           </a:p>
         </p:txBody>

</xml_diff>